<commit_message>
Mark MagicBlock and ZK Compression as future roadmap in docs and PPT
MagicBlock high-frequency channels, state channels, and ZK Compression
DID are not currently used. Update demo script, e2e test guide, and
both Chinese/English presentations to reflect current capabilities:
4 active payment paths (Session Key, Direct Wallet, Relayer, CCTP)
with MagicBlock and ZK Compression clearly labeled as planned features.

Co-Authored-By: Claude Opus 4.5 <noreply@anthropic.com>
</commit_message>
<xml_diff>
--- a/IgnitePay-Demo-EN.pptx
+++ b/IgnitePay-Demo-EN.pptx
@@ -2548,7 +2548,7 @@
                 <a:ea typeface="Calibri" pitchFamily="34" charset="-122"/>
                 <a:cs typeface="Calibri" pitchFamily="34" charset="-120"/>
               </a:rPr>
-              <a:t>MagicBlock</a:t>
+              <a:t>Full Rust</a:t>
             </a:r>
             <a:endParaRPr lang="en-US" sz="900" dirty="0"/>
           </a:p>
@@ -3960,7 +3960,7 @@
                 <a:ea typeface="Calibri" pitchFamily="34" charset="-122"/>
                 <a:cs typeface="Calibri" pitchFamily="34" charset="-120"/>
               </a:rPr>
-              <a:t>DID (6 instr.) / Session Key (4) / MagicBlock (10)</a:t>
+              <a:t>DID (6 instr.) / Session Key (4) / Merchant (3)</a:t>
             </a:r>
             <a:endParaRPr lang="en-US" sz="900" dirty="0"/>
           </a:p>
@@ -5576,374 +5576,6 @@
           </a:p>
         </p:txBody>
       </p:sp>
-      <p:sp>
-        <p:nvSpPr>
-          <p:cNvPr id="26" name="Shape 23"/>
-          <p:cNvSpPr/>
-          <p:nvPr/>
-        </p:nvSpPr>
-        <p:spPr>
-          <a:xfrm>
-            <a:off x="457200" y="3657600"/>
-            <a:ext cx="8229600" cy="1051560"/>
-          </a:xfrm>
-          <a:prstGeom prst="rect">
-            <a:avLst/>
-          </a:prstGeom>
-          <a:solidFill>
-            <a:srgbClr val="151829"/>
-          </a:solidFill>
-          <a:ln/>
-          <a:effectLst>
-            <a:outerShdw sx="100000" sy="100000" kx="0" ky="0" algn="bl" rotWithShape="0" blurRad="101600" dist="38100" dir="8100000">
-              <a:srgbClr val="000000">
-                <a:alpha val="30000"/>
-              </a:srgbClr>
-            </a:outerShdw>
-          </a:effectLst>
-        </p:spPr>
-      </p:sp>
-      <p:sp>
-        <p:nvSpPr>
-          <p:cNvPr id="27" name="Shape 24"/>
-          <p:cNvSpPr/>
-          <p:nvPr/>
-        </p:nvSpPr>
-        <p:spPr>
-          <a:xfrm>
-            <a:off x="457200" y="3657600"/>
-            <a:ext cx="73152" cy="1051560"/>
-          </a:xfrm>
-          <a:prstGeom prst="rect">
-            <a:avLst/>
-          </a:prstGeom>
-          <a:solidFill>
-            <a:srgbClr val="F59E0B"/>
-          </a:solidFill>
-          <a:ln/>
-        </p:spPr>
-      </p:sp>
-      <p:sp>
-        <p:nvSpPr>
-          <p:cNvPr id="28" name="Text 25"/>
-          <p:cNvSpPr/>
-          <p:nvPr/>
-        </p:nvSpPr>
-        <p:spPr>
-          <a:xfrm>
-            <a:off x="731520" y="3749040"/>
-            <a:ext cx="731520" cy="868680"/>
-          </a:xfrm>
-          <a:prstGeom prst="rect">
-            <a:avLst/>
-          </a:prstGeom>
-          <a:noFill/>
-          <a:ln/>
-        </p:spPr>
-        <p:txBody>
-          <a:bodyPr wrap="square" lIns="0" tIns="0" rIns="0" bIns="0" rtlCol="0" anchor="ctr"/>
-          <a:lstStyle/>
-          <a:p>
-            <a:pPr indent="0" marL="0">
-              <a:buNone/>
-            </a:pPr>
-            <a:r>
-              <a:rPr lang="en-US" sz="3000" dirty="0">
-                <a:solidFill>
-                  <a:srgbClr val="F59E0B"/>
-                </a:solidFill>
-                <a:latin typeface="Arial Black" pitchFamily="34" charset="0"/>
-                <a:ea typeface="Arial Black" pitchFamily="34" charset="-122"/>
-                <a:cs typeface="Arial Black" pitchFamily="34" charset="-120"/>
-              </a:rPr>
-              <a:t>03</a:t>
-            </a:r>
-            <a:endParaRPr lang="en-US" sz="3000" dirty="0"/>
-          </a:p>
-        </p:txBody>
-      </p:sp>
-      <p:sp>
-        <p:nvSpPr>
-          <p:cNvPr id="29" name="Text 26"/>
-          <p:cNvSpPr/>
-          <p:nvPr/>
-        </p:nvSpPr>
-        <p:spPr>
-          <a:xfrm>
-            <a:off x="1554480" y="3749040"/>
-            <a:ext cx="3657600" cy="365760"/>
-          </a:xfrm>
-          <a:prstGeom prst="rect">
-            <a:avLst/>
-          </a:prstGeom>
-          <a:noFill/>
-          <a:ln/>
-        </p:spPr>
-        <p:txBody>
-          <a:bodyPr wrap="square" lIns="0" tIns="0" rIns="0" bIns="0" rtlCol="0" anchor="ctr"/>
-          <a:lstStyle/>
-          <a:p>
-            <a:pPr indent="0" marL="0">
-              <a:buNone/>
-            </a:pPr>
-            <a:r>
-              <a:rPr lang="en-US" sz="1500" b="1" dirty="0">
-                <a:solidFill>
-                  <a:srgbClr val="FFFFFF"/>
-                </a:solidFill>
-                <a:latin typeface="Arial" pitchFamily="34" charset="0"/>
-                <a:ea typeface="Arial" pitchFamily="34" charset="-122"/>
-                <a:cs typeface="Arial" pitchFamily="34" charset="-120"/>
-              </a:rPr>
-              <a:t>MagicBlock High-Freq</a:t>
-            </a:r>
-            <a:endParaRPr lang="en-US" sz="1500" dirty="0"/>
-          </a:p>
-        </p:txBody>
-      </p:sp>
-      <p:sp>
-        <p:nvSpPr>
-          <p:cNvPr id="30" name="Text 27"/>
-          <p:cNvSpPr/>
-          <p:nvPr/>
-        </p:nvSpPr>
-        <p:spPr>
-          <a:xfrm>
-            <a:off x="1554480" y="4160520"/>
-            <a:ext cx="3657600" cy="365760"/>
-          </a:xfrm>
-          <a:prstGeom prst="rect">
-            <a:avLst/>
-          </a:prstGeom>
-          <a:noFill/>
-          <a:ln/>
-        </p:spPr>
-        <p:txBody>
-          <a:bodyPr wrap="square" lIns="0" tIns="0" rIns="0" bIns="0" rtlCol="0" anchor="ctr"/>
-          <a:lstStyle/>
-          <a:p>
-            <a:pPr indent="0" marL="0">
-              <a:buNone/>
-            </a:pPr>
-            <a:r>
-              <a:rPr lang="en-US" sz="1000" dirty="0">
-                <a:solidFill>
-                  <a:srgbClr val="C4C4D4"/>
-                </a:solidFill>
-                <a:latin typeface="Calibri" pitchFamily="34" charset="0"/>
-                <a:ea typeface="Calibri" pitchFamily="34" charset="-122"/>
-                <a:cs typeface="Calibri" pitchFamily="34" charset="-120"/>
-              </a:rPr>
-              <a:t>Off-chain Voucher signing → sub-second completion → Sum-Merkle batch settlement</a:t>
-            </a:r>
-            <a:endParaRPr lang="en-US" sz="1000" dirty="0"/>
-          </a:p>
-        </p:txBody>
-      </p:sp>
-      <p:sp>
-        <p:nvSpPr>
-          <p:cNvPr id="31" name="Shape 28"/>
-          <p:cNvSpPr/>
-          <p:nvPr/>
-        </p:nvSpPr>
-        <p:spPr>
-          <a:xfrm>
-            <a:off x="5669280" y="3931920"/>
-            <a:ext cx="914400" cy="274320"/>
-          </a:xfrm>
-          <a:prstGeom prst="rect">
-            <a:avLst>
-              <a:gd name="adj" fmla="val 16667"/>
-            </a:avLst>
-          </a:prstGeom>
-          <a:solidFill>
-            <a:srgbClr val="F59E0B">
-              <a:alpha val="20000"/>
-            </a:srgbClr>
-          </a:solidFill>
-          <a:ln w="6350">
-            <a:solidFill>
-              <a:srgbClr val="F59E0B"/>
-            </a:solidFill>
-            <a:prstDash val="solid"/>
-          </a:ln>
-        </p:spPr>
-      </p:sp>
-      <p:sp>
-        <p:nvSpPr>
-          <p:cNvPr id="32" name="Text 29"/>
-          <p:cNvSpPr/>
-          <p:nvPr/>
-        </p:nvSpPr>
-        <p:spPr>
-          <a:xfrm>
-            <a:off x="5669280" y="3931920"/>
-            <a:ext cx="914400" cy="274320"/>
-          </a:xfrm>
-          <a:prstGeom prst="rect">
-            <a:avLst/>
-          </a:prstGeom>
-          <a:noFill/>
-          <a:ln/>
-        </p:spPr>
-        <p:txBody>
-          <a:bodyPr wrap="square" lIns="0" tIns="0" rIns="0" bIns="0" rtlCol="0" anchor="ctr"/>
-          <a:lstStyle/>
-          <a:p>
-            <a:pPr algn="ctr" indent="0" marL="0">
-              <a:buNone/>
-            </a:pPr>
-            <a:r>
-              <a:rPr lang="en-US" sz="700" dirty="0">
-                <a:solidFill>
-                  <a:srgbClr val="F59E0B"/>
-                </a:solidFill>
-                <a:latin typeface="Consolas" pitchFamily="34" charset="0"/>
-                <a:ea typeface="Consolas" pitchFamily="34" charset="-122"/>
-                <a:cs typeface="Consolas" pitchFamily="34" charset="-120"/>
-              </a:rPr>
-              <a:t>Voucher</a:t>
-            </a:r>
-            <a:endParaRPr lang="en-US" sz="700" dirty="0"/>
-          </a:p>
-        </p:txBody>
-      </p:sp>
-      <p:sp>
-        <p:nvSpPr>
-          <p:cNvPr id="33" name="Shape 30"/>
-          <p:cNvSpPr/>
-          <p:nvPr/>
-        </p:nvSpPr>
-        <p:spPr>
-          <a:xfrm>
-            <a:off x="6675120" y="3931920"/>
-            <a:ext cx="914400" cy="274320"/>
-          </a:xfrm>
-          <a:prstGeom prst="rect">
-            <a:avLst>
-              <a:gd name="adj" fmla="val 16667"/>
-            </a:avLst>
-          </a:prstGeom>
-          <a:solidFill>
-            <a:srgbClr val="F59E0B">
-              <a:alpha val="20000"/>
-            </a:srgbClr>
-          </a:solidFill>
-          <a:ln w="6350">
-            <a:solidFill>
-              <a:srgbClr val="F59E0B"/>
-            </a:solidFill>
-            <a:prstDash val="solid"/>
-          </a:ln>
-        </p:spPr>
-      </p:sp>
-      <p:sp>
-        <p:nvSpPr>
-          <p:cNvPr id="34" name="Text 31"/>
-          <p:cNvSpPr/>
-          <p:nvPr/>
-        </p:nvSpPr>
-        <p:spPr>
-          <a:xfrm>
-            <a:off x="6675120" y="3931920"/>
-            <a:ext cx="914400" cy="274320"/>
-          </a:xfrm>
-          <a:prstGeom prst="rect">
-            <a:avLst/>
-          </a:prstGeom>
-          <a:noFill/>
-          <a:ln/>
-        </p:spPr>
-        <p:txBody>
-          <a:bodyPr wrap="square" lIns="0" tIns="0" rIns="0" bIns="0" rtlCol="0" anchor="ctr"/>
-          <a:lstStyle/>
-          <a:p>
-            <a:pPr algn="ctr" indent="0" marL="0">
-              <a:buNone/>
-            </a:pPr>
-            <a:r>
-              <a:rPr lang="en-US" sz="700" dirty="0">
-                <a:solidFill>
-                  <a:srgbClr val="F59E0B"/>
-                </a:solidFill>
-                <a:latin typeface="Consolas" pitchFamily="34" charset="0"/>
-                <a:ea typeface="Consolas" pitchFamily="34" charset="-122"/>
-                <a:cs typeface="Consolas" pitchFamily="34" charset="-120"/>
-              </a:rPr>
-              <a:t>&lt;50ms</a:t>
-            </a:r>
-            <a:endParaRPr lang="en-US" sz="700" dirty="0"/>
-          </a:p>
-        </p:txBody>
-      </p:sp>
-      <p:sp>
-        <p:nvSpPr>
-          <p:cNvPr id="35" name="Shape 32"/>
-          <p:cNvSpPr/>
-          <p:nvPr/>
-        </p:nvSpPr>
-        <p:spPr>
-          <a:xfrm>
-            <a:off x="7680960" y="3931920"/>
-            <a:ext cx="914400" cy="274320"/>
-          </a:xfrm>
-          <a:prstGeom prst="rect">
-            <a:avLst>
-              <a:gd name="adj" fmla="val 16667"/>
-            </a:avLst>
-          </a:prstGeom>
-          <a:solidFill>
-            <a:srgbClr val="F59E0B">
-              <a:alpha val="20000"/>
-            </a:srgbClr>
-          </a:solidFill>
-          <a:ln w="6350">
-            <a:solidFill>
-              <a:srgbClr val="F59E0B"/>
-            </a:solidFill>
-            <a:prstDash val="solid"/>
-          </a:ln>
-        </p:spPr>
-      </p:sp>
-      <p:sp>
-        <p:nvSpPr>
-          <p:cNvPr id="36" name="Text 33"/>
-          <p:cNvSpPr/>
-          <p:nvPr/>
-        </p:nvSpPr>
-        <p:spPr>
-          <a:xfrm>
-            <a:off x="7680960" y="3931920"/>
-            <a:ext cx="914400" cy="274320"/>
-          </a:xfrm>
-          <a:prstGeom prst="rect">
-            <a:avLst/>
-          </a:prstGeom>
-          <a:noFill/>
-          <a:ln/>
-        </p:spPr>
-        <p:txBody>
-          <a:bodyPr wrap="square" lIns="0" tIns="0" rIns="0" bIns="0" rtlCol="0" anchor="ctr"/>
-          <a:lstStyle/>
-          <a:p>
-            <a:pPr algn="ctr" indent="0" marL="0">
-              <a:buNone/>
-            </a:pPr>
-            <a:r>
-              <a:rPr lang="en-US" sz="700" dirty="0">
-                <a:solidFill>
-                  <a:srgbClr val="F59E0B"/>
-                </a:solidFill>
-                <a:latin typeface="Consolas" pitchFamily="34" charset="0"/>
-                <a:ea typeface="Consolas" pitchFamily="34" charset="-122"/>
-                <a:cs typeface="Consolas" pitchFamily="34" charset="-120"/>
-              </a:rPr>
-              <a:t>Batch Settle</a:t>
-            </a:r>
-            <a:endParaRPr lang="en-US" sz="700" dirty="0"/>
-          </a:p>
-        </p:txBody>
-      </p:sp>
     </p:spTree>
   </p:cSld>
   <p:clrMapOvr>
@@ -6987,7 +6619,7 @@
                 <a:ea typeface="Calibri" pitchFamily="34" charset="-122"/>
                 <a:cs typeface="Calibri" pitchFamily="34" charset="-120"/>
               </a:rPr>
-              <a:t>5 payment paths — MagicBlock sub-second, gas-free</a:t>
+              <a:t>4 payment paths — auto-selected for optimal routing</a:t>
             </a:r>
             <a:endParaRPr lang="en-US" sz="1400" dirty="0"/>
           </a:p>
@@ -8703,7 +8335,7 @@
                 <a:ea typeface="Calibri" pitchFamily="34" charset="-122"/>
                 <a:cs typeface="Calibri" pitchFamily="34" charset="-120"/>
               </a:rPr>
-              <a:t>MagicBlock</a:t>
+              <a:t>Relayer sponsored</a:t>
             </a:r>
             <a:endParaRPr lang="en-US" sz="900" dirty="0"/>
           </a:p>
@@ -9039,7 +8671,7 @@
                 <a:ea typeface="Calibri" pitchFamily="34" charset="-122"/>
                 <a:cs typeface="Calibri" pitchFamily="34" charset="-120"/>
               </a:rPr>
-              <a:t>5 payment paths auto-selected</a:t>
+              <a:t>4 payment paths auto-selected</a:t>
             </a:r>
             <a:endParaRPr lang="en-US" sz="900" dirty="0"/>
           </a:p>
@@ -9156,7 +8788,7 @@
                 <a:ea typeface="Arial" pitchFamily="34" charset="-122"/>
                 <a:cs typeface="Arial" pitchFamily="34" charset="-120"/>
               </a:rPr>
-              <a:t>Sub-second Settlement</a:t>
+              <a:t>Full Rust Backend</a:t>
             </a:r>
             <a:endParaRPr lang="en-US" sz="1200" dirty="0"/>
           </a:p>
@@ -9195,7 +8827,7 @@
                 <a:ea typeface="Calibri" pitchFamily="34" charset="-122"/>
                 <a:cs typeface="Calibri" pitchFamily="34" charset="-120"/>
               </a:rPr>
-              <a:t>MagicBlock &lt;50ms</a:t>
+              <a:t>17+ crates high-performance stack</a:t>
             </a:r>
             <a:endParaRPr lang="en-US" sz="900" dirty="0"/>
           </a:p>
@@ -9777,7 +9409,7 @@
                 <a:ea typeface="Calibri" pitchFamily="34" charset="-122"/>
                 <a:cs typeface="Calibri" pitchFamily="34" charset="-120"/>
               </a:rPr>
-              <a:t>Solana Settlement  |  MagicBlock ER  |  ZK Compression DID</a:t>
+              <a:t>Solana Settlement  |  DID Registry  |  Session Key Program</a:t>
             </a:r>
             <a:endParaRPr lang="en-US" sz="1100" dirty="0"/>
           </a:p>
@@ -10561,8 +10193,8 @@
         </p:nvSpPr>
         <p:spPr>
           <a:xfrm>
-            <a:off x="274320" y="1097280"/>
-            <a:ext cx="1645920" cy="3291840"/>
+            <a:off x="320040" y="1097280"/>
+            <a:ext cx="1920240" cy="3291840"/>
           </a:xfrm>
           <a:prstGeom prst="rect">
             <a:avLst/>
@@ -10588,14 +10220,14 @@
         </p:nvSpPr>
         <p:spPr>
           <a:xfrm>
-            <a:off x="274320" y="1097280"/>
-            <a:ext cx="1645920" cy="45720"/>
+            <a:off x="320040" y="1097280"/>
+            <a:ext cx="1920240" cy="45720"/>
           </a:xfrm>
           <a:prstGeom prst="rect">
             <a:avLst/>
           </a:prstGeom>
           <a:solidFill>
-            <a:srgbClr val="14F195"/>
+            <a:srgbClr val="9945FF"/>
           </a:solidFill>
           <a:ln/>
         </p:spPr>
@@ -10608,8 +10240,8 @@
         </p:nvSpPr>
         <p:spPr>
           <a:xfrm>
-            <a:off x="411480" y="1280160"/>
-            <a:ext cx="1371600" cy="320040"/>
+            <a:off x="457200" y="1280160"/>
+            <a:ext cx="1645920" cy="320040"/>
           </a:xfrm>
           <a:prstGeom prst="rect">
             <a:avLst/>
@@ -10627,13 +10259,13 @@
             <a:r>
               <a:rPr lang="en-US" sz="1300" b="1" dirty="0">
                 <a:solidFill>
-                  <a:srgbClr val="14F195"/>
+                  <a:srgbClr val="9945FF"/>
                 </a:solidFill>
                 <a:latin typeface="Arial" pitchFamily="34" charset="0"/>
                 <a:ea typeface="Arial" pitchFamily="34" charset="-122"/>
                 <a:cs typeface="Arial" pitchFamily="34" charset="-120"/>
               </a:rPr>
-              <a:t>MagicBlock</a:t>
+              <a:t>Session Key</a:t>
             </a:r>
             <a:endParaRPr lang="en-US" sz="1300" dirty="0"/>
           </a:p>
@@ -10647,8 +10279,8 @@
         </p:nvSpPr>
         <p:spPr>
           <a:xfrm>
-            <a:off x="411480" y="1737360"/>
-            <a:ext cx="1371600" cy="365760"/>
+            <a:off x="457200" y="1737360"/>
+            <a:ext cx="1645920" cy="365760"/>
           </a:xfrm>
           <a:prstGeom prst="rect">
             <a:avLst/>
@@ -10672,7 +10304,7 @@
                 <a:ea typeface="Arial Black" pitchFamily="34" charset="-122"/>
                 <a:cs typeface="Arial Black" pitchFamily="34" charset="-120"/>
               </a:rPr>
-              <a:t>&lt;50ms</a:t>
+              <a:t>~400ms</a:t>
             </a:r>
             <a:endParaRPr lang="en-US" sz="2000" dirty="0"/>
           </a:p>
@@ -10686,8 +10318,8 @@
         </p:nvSpPr>
         <p:spPr>
           <a:xfrm>
-            <a:off x="411480" y="2103120"/>
-            <a:ext cx="1371600" cy="228600"/>
+            <a:off x="457200" y="2103120"/>
+            <a:ext cx="1645920" cy="228600"/>
           </a:xfrm>
           <a:prstGeom prst="rect">
             <a:avLst/>
@@ -10725,8 +10357,8 @@
         </p:nvSpPr>
         <p:spPr>
           <a:xfrm>
-            <a:off x="411480" y="2514600"/>
-            <a:ext cx="1371600" cy="274320"/>
+            <a:off x="457200" y="2514600"/>
+            <a:ext cx="1645920" cy="274320"/>
           </a:xfrm>
           <a:prstGeom prst="rect">
             <a:avLst/>
@@ -10745,8 +10377,8 @@
         </p:nvSpPr>
         <p:spPr>
           <a:xfrm>
-            <a:off x="411480" y="2514600"/>
-            <a:ext cx="1371600" cy="274320"/>
+            <a:off x="457200" y="2514600"/>
+            <a:ext cx="1645920" cy="274320"/>
           </a:xfrm>
           <a:prstGeom prst="rect">
             <a:avLst/>
@@ -10770,7 +10402,7 @@
                 <a:ea typeface="Consolas" pitchFamily="34" charset="-122"/>
                 <a:cs typeface="Consolas" pitchFamily="34" charset="-120"/>
               </a:rPr>
-              <a:t>Gas: Free</a:t>
+              <a:t>Gas: Normal</a:t>
             </a:r>
             <a:endParaRPr lang="en-US" sz="900" dirty="0"/>
           </a:p>
@@ -10784,8 +10416,8 @@
         </p:nvSpPr>
         <p:spPr>
           <a:xfrm>
-            <a:off x="411480" y="3017520"/>
-            <a:ext cx="1371600" cy="914400"/>
+            <a:off x="457200" y="3017520"/>
+            <a:ext cx="1645920" cy="914400"/>
           </a:xfrm>
           <a:prstGeom prst="rect">
             <a:avLst/>
@@ -10812,7 +10444,7 @@
                 <a:ea typeface="Calibri" pitchFamily="34" charset="-122"/>
                 <a:cs typeface="Calibri" pitchFamily="34" charset="-120"/>
               </a:rPr>
-              <a:t>Off-chain Voucher</a:t>
+              <a:t>On-chain SOL/SPL</a:t>
             </a:r>
             <a:endParaRPr lang="en-US" sz="1000" dirty="0"/>
           </a:p>
@@ -10832,7 +10464,7 @@
                 <a:ea typeface="Calibri" pitchFamily="34" charset="-122"/>
                 <a:cs typeface="Calibri" pitchFamily="34" charset="-120"/>
               </a:rPr>
-              <a:t>Batch Merkle settlement</a:t>
+              <a:t>Temporary key auth</a:t>
             </a:r>
             <a:endParaRPr lang="en-US" sz="1000" dirty="0"/>
           </a:p>
@@ -10846,8 +10478,8 @@
         </p:nvSpPr>
         <p:spPr>
           <a:xfrm>
-            <a:off x="2057400" y="1097280"/>
-            <a:ext cx="1645920" cy="3291840"/>
+            <a:off x="2423160" y="1097280"/>
+            <a:ext cx="1920240" cy="3291840"/>
           </a:xfrm>
           <a:prstGeom prst="rect">
             <a:avLst/>
@@ -10873,14 +10505,14 @@
         </p:nvSpPr>
         <p:spPr>
           <a:xfrm>
-            <a:off x="2057400" y="1097280"/>
-            <a:ext cx="1645920" cy="45720"/>
+            <a:off x="2423160" y="1097280"/>
+            <a:ext cx="1920240" cy="45720"/>
           </a:xfrm>
           <a:prstGeom prst="rect">
             <a:avLst/>
           </a:prstGeom>
           <a:solidFill>
-            <a:srgbClr val="9945FF"/>
+            <a:srgbClr val="6366F1"/>
           </a:solidFill>
           <a:ln/>
         </p:spPr>
@@ -10893,8 +10525,8 @@
         </p:nvSpPr>
         <p:spPr>
           <a:xfrm>
-            <a:off x="2194560" y="1280160"/>
-            <a:ext cx="1371600" cy="320040"/>
+            <a:off x="2560320" y="1280160"/>
+            <a:ext cx="1645920" cy="320040"/>
           </a:xfrm>
           <a:prstGeom prst="rect">
             <a:avLst/>
@@ -10912,13 +10544,13 @@
             <a:r>
               <a:rPr lang="en-US" sz="1300" b="1" dirty="0">
                 <a:solidFill>
-                  <a:srgbClr val="9945FF"/>
+                  <a:srgbClr val="6366F1"/>
                 </a:solidFill>
                 <a:latin typeface="Arial" pitchFamily="34" charset="0"/>
                 <a:ea typeface="Arial" pitchFamily="34" charset="-122"/>
                 <a:cs typeface="Arial" pitchFamily="34" charset="-120"/>
               </a:rPr>
-              <a:t>Session Key</a:t>
+              <a:t>Direct Wallet</a:t>
             </a:r>
             <a:endParaRPr lang="en-US" sz="1300" dirty="0"/>
           </a:p>
@@ -10932,8 +10564,8 @@
         </p:nvSpPr>
         <p:spPr>
           <a:xfrm>
-            <a:off x="2194560" y="1737360"/>
-            <a:ext cx="1371600" cy="365760"/>
+            <a:off x="2560320" y="1737360"/>
+            <a:ext cx="1645920" cy="365760"/>
           </a:xfrm>
           <a:prstGeom prst="rect">
             <a:avLst/>
@@ -10971,8 +10603,8 @@
         </p:nvSpPr>
         <p:spPr>
           <a:xfrm>
-            <a:off x="2194560" y="2103120"/>
-            <a:ext cx="1371600" cy="228600"/>
+            <a:off x="2560320" y="2103120"/>
+            <a:ext cx="1645920" cy="228600"/>
           </a:xfrm>
           <a:prstGeom prst="rect">
             <a:avLst/>
@@ -11010,8 +10642,8 @@
         </p:nvSpPr>
         <p:spPr>
           <a:xfrm>
-            <a:off x="2194560" y="2514600"/>
-            <a:ext cx="1371600" cy="274320"/>
+            <a:off x="2560320" y="2514600"/>
+            <a:ext cx="1645920" cy="274320"/>
           </a:xfrm>
           <a:prstGeom prst="rect">
             <a:avLst/>
@@ -11030,8 +10662,8 @@
         </p:nvSpPr>
         <p:spPr>
           <a:xfrm>
-            <a:off x="2194560" y="2514600"/>
-            <a:ext cx="1371600" cy="274320"/>
+            <a:off x="2560320" y="2514600"/>
+            <a:ext cx="1645920" cy="274320"/>
           </a:xfrm>
           <a:prstGeom prst="rect">
             <a:avLst/>
@@ -11069,8 +10701,8 @@
         </p:nvSpPr>
         <p:spPr>
           <a:xfrm>
-            <a:off x="2194560" y="3017520"/>
-            <a:ext cx="1371600" cy="914400"/>
+            <a:off x="2560320" y="3017520"/>
+            <a:ext cx="1645920" cy="914400"/>
           </a:xfrm>
           <a:prstGeom prst="rect">
             <a:avLst/>
@@ -11097,7 +10729,7 @@
                 <a:ea typeface="Calibri" pitchFamily="34" charset="-122"/>
                 <a:cs typeface="Calibri" pitchFamily="34" charset="-120"/>
               </a:rPr>
-              <a:t>On-chain SOL/SPL</a:t>
+              <a:t>Phantom / Solflare</a:t>
             </a:r>
             <a:endParaRPr lang="en-US" sz="1000" dirty="0"/>
           </a:p>
@@ -11117,7 +10749,7 @@
                 <a:ea typeface="Calibri" pitchFamily="34" charset="-122"/>
                 <a:cs typeface="Calibri" pitchFamily="34" charset="-120"/>
               </a:rPr>
-              <a:t>Temporary key auth</a:t>
+              <a:t>Deep Link signing</a:t>
             </a:r>
             <a:endParaRPr lang="en-US" sz="1000" dirty="0"/>
           </a:p>
@@ -11131,8 +10763,8 @@
         </p:nvSpPr>
         <p:spPr>
           <a:xfrm>
-            <a:off x="3840480" y="1097280"/>
-            <a:ext cx="1645920" cy="3291840"/>
+            <a:off x="4526280" y="1097280"/>
+            <a:ext cx="1920240" cy="3291840"/>
           </a:xfrm>
           <a:prstGeom prst="rect">
             <a:avLst/>
@@ -11158,14 +10790,14 @@
         </p:nvSpPr>
         <p:spPr>
           <a:xfrm>
-            <a:off x="3840480" y="1097280"/>
-            <a:ext cx="1645920" cy="45720"/>
+            <a:off x="4526280" y="1097280"/>
+            <a:ext cx="1920240" cy="45720"/>
           </a:xfrm>
           <a:prstGeom prst="rect">
             <a:avLst/>
           </a:prstGeom>
           <a:solidFill>
-            <a:srgbClr val="6366F1"/>
+            <a:srgbClr val="F59E0B"/>
           </a:solidFill>
           <a:ln/>
         </p:spPr>
@@ -11178,8 +10810,8 @@
         </p:nvSpPr>
         <p:spPr>
           <a:xfrm>
-            <a:off x="3977640" y="1280160"/>
-            <a:ext cx="1371600" cy="320040"/>
+            <a:off x="4663440" y="1280160"/>
+            <a:ext cx="1645920" cy="320040"/>
           </a:xfrm>
           <a:prstGeom prst="rect">
             <a:avLst/>
@@ -11197,13 +10829,13 @@
             <a:r>
               <a:rPr lang="en-US" sz="1300" b="1" dirty="0">
                 <a:solidFill>
-                  <a:srgbClr val="6366F1"/>
+                  <a:srgbClr val="F59E0B"/>
                 </a:solidFill>
                 <a:latin typeface="Arial" pitchFamily="34" charset="0"/>
                 <a:ea typeface="Arial" pitchFamily="34" charset="-122"/>
                 <a:cs typeface="Arial" pitchFamily="34" charset="-120"/>
               </a:rPr>
-              <a:t>Direct Wallet</a:t>
+              <a:t>Relayer</a:t>
             </a:r>
             <a:endParaRPr lang="en-US" sz="1300" dirty="0"/>
           </a:p>
@@ -11217,8 +10849,8 @@
         </p:nvSpPr>
         <p:spPr>
           <a:xfrm>
-            <a:off x="3977640" y="1737360"/>
-            <a:ext cx="1371600" cy="365760"/>
+            <a:off x="4663440" y="1737360"/>
+            <a:ext cx="1645920" cy="365760"/>
           </a:xfrm>
           <a:prstGeom prst="rect">
             <a:avLst/>
@@ -11256,8 +10888,8 @@
         </p:nvSpPr>
         <p:spPr>
           <a:xfrm>
-            <a:off x="3977640" y="2103120"/>
-            <a:ext cx="1371600" cy="228600"/>
+            <a:off x="4663440" y="2103120"/>
+            <a:ext cx="1645920" cy="228600"/>
           </a:xfrm>
           <a:prstGeom prst="rect">
             <a:avLst/>
@@ -11295,8 +10927,8 @@
         </p:nvSpPr>
         <p:spPr>
           <a:xfrm>
-            <a:off x="3977640" y="2514600"/>
-            <a:ext cx="1371600" cy="274320"/>
+            <a:off x="4663440" y="2514600"/>
+            <a:ext cx="1645920" cy="274320"/>
           </a:xfrm>
           <a:prstGeom prst="rect">
             <a:avLst/>
@@ -11315,8 +10947,8 @@
         </p:nvSpPr>
         <p:spPr>
           <a:xfrm>
-            <a:off x="3977640" y="2514600"/>
-            <a:ext cx="1371600" cy="274320"/>
+            <a:off x="4663440" y="2514600"/>
+            <a:ext cx="1645920" cy="274320"/>
           </a:xfrm>
           <a:prstGeom prst="rect">
             <a:avLst/>
@@ -11340,7 +10972,7 @@
                 <a:ea typeface="Consolas" pitchFamily="34" charset="-122"/>
                 <a:cs typeface="Consolas" pitchFamily="34" charset="-120"/>
               </a:rPr>
-              <a:t>Gas: Normal</a:t>
+              <a:t>Gas: Sponsored</a:t>
             </a:r>
             <a:endParaRPr lang="en-US" sz="900" dirty="0"/>
           </a:p>
@@ -11354,8 +10986,8 @@
         </p:nvSpPr>
         <p:spPr>
           <a:xfrm>
-            <a:off x="3977640" y="3017520"/>
-            <a:ext cx="1371600" cy="914400"/>
+            <a:off x="4663440" y="3017520"/>
+            <a:ext cx="1645920" cy="914400"/>
           </a:xfrm>
           <a:prstGeom prst="rect">
             <a:avLst/>
@@ -11382,7 +11014,7 @@
                 <a:ea typeface="Calibri" pitchFamily="34" charset="-122"/>
                 <a:cs typeface="Calibri" pitchFamily="34" charset="-120"/>
               </a:rPr>
-              <a:t>Phantom / Solflare</a:t>
+              <a:t>Sponsored gas</a:t>
             </a:r>
             <a:endParaRPr lang="en-US" sz="1000" dirty="0"/>
           </a:p>
@@ -11402,7 +11034,7 @@
                 <a:ea typeface="Calibri" pitchFamily="34" charset="-122"/>
                 <a:cs typeface="Calibri" pitchFamily="34" charset="-120"/>
               </a:rPr>
-              <a:t>Deep Link signing</a:t>
+              <a:t>Zero-barrier onboarding</a:t>
             </a:r>
             <a:endParaRPr lang="en-US" sz="1000" dirty="0"/>
           </a:p>
@@ -11416,8 +11048,8 @@
         </p:nvSpPr>
         <p:spPr>
           <a:xfrm>
-            <a:off x="5623560" y="1097280"/>
-            <a:ext cx="1645920" cy="3291840"/>
+            <a:off x="6629400" y="1097280"/>
+            <a:ext cx="1920240" cy="3291840"/>
           </a:xfrm>
           <a:prstGeom prst="rect">
             <a:avLst/>
@@ -11443,14 +11075,14 @@
         </p:nvSpPr>
         <p:spPr>
           <a:xfrm>
-            <a:off x="5623560" y="1097280"/>
-            <a:ext cx="1645920" cy="45720"/>
+            <a:off x="6629400" y="1097280"/>
+            <a:ext cx="1920240" cy="45720"/>
           </a:xfrm>
           <a:prstGeom prst="rect">
             <a:avLst/>
           </a:prstGeom>
           <a:solidFill>
-            <a:srgbClr val="F59E0B"/>
+            <a:srgbClr val="06B6D4"/>
           </a:solidFill>
           <a:ln/>
         </p:spPr>
@@ -11463,8 +11095,8 @@
         </p:nvSpPr>
         <p:spPr>
           <a:xfrm>
-            <a:off x="5760720" y="1280160"/>
-            <a:ext cx="1371600" cy="320040"/>
+            <a:off x="6766560" y="1280160"/>
+            <a:ext cx="1645920" cy="320040"/>
           </a:xfrm>
           <a:prstGeom prst="rect">
             <a:avLst/>
@@ -11482,13 +11114,13 @@
             <a:r>
               <a:rPr lang="en-US" sz="1300" b="1" dirty="0">
                 <a:solidFill>
-                  <a:srgbClr val="F59E0B"/>
+                  <a:srgbClr val="06B6D4"/>
                 </a:solidFill>
                 <a:latin typeface="Arial" pitchFamily="34" charset="0"/>
                 <a:ea typeface="Arial" pitchFamily="34" charset="-122"/>
                 <a:cs typeface="Arial" pitchFamily="34" charset="-120"/>
               </a:rPr>
-              <a:t>Relayer</a:t>
+              <a:t>CCTP</a:t>
             </a:r>
             <a:endParaRPr lang="en-US" sz="1300" dirty="0"/>
           </a:p>
@@ -11502,8 +11134,8 @@
         </p:nvSpPr>
         <p:spPr>
           <a:xfrm>
-            <a:off x="5760720" y="1737360"/>
-            <a:ext cx="1371600" cy="365760"/>
+            <a:off x="6766560" y="1737360"/>
+            <a:ext cx="1645920" cy="365760"/>
           </a:xfrm>
           <a:prstGeom prst="rect">
             <a:avLst/>
@@ -11527,7 +11159,7 @@
                 <a:ea typeface="Arial Black" pitchFamily="34" charset="-122"/>
                 <a:cs typeface="Arial Black" pitchFamily="34" charset="-120"/>
               </a:rPr>
-              <a:t>~400ms</a:t>
+              <a:t>10-30min</a:t>
             </a:r>
             <a:endParaRPr lang="en-US" sz="2000" dirty="0"/>
           </a:p>
@@ -11541,8 +11173,8 @@
         </p:nvSpPr>
         <p:spPr>
           <a:xfrm>
-            <a:off x="5760720" y="2103120"/>
-            <a:ext cx="1371600" cy="228600"/>
+            <a:off x="6766560" y="2103120"/>
+            <a:ext cx="1645920" cy="228600"/>
           </a:xfrm>
           <a:prstGeom prst="rect">
             <a:avLst/>
@@ -11580,8 +11212,8 @@
         </p:nvSpPr>
         <p:spPr>
           <a:xfrm>
-            <a:off x="5760720" y="2514600"/>
-            <a:ext cx="1371600" cy="274320"/>
+            <a:off x="6766560" y="2514600"/>
+            <a:ext cx="1645920" cy="274320"/>
           </a:xfrm>
           <a:prstGeom prst="rect">
             <a:avLst/>
@@ -11600,8 +11232,8 @@
         </p:nvSpPr>
         <p:spPr>
           <a:xfrm>
-            <a:off x="5760720" y="2514600"/>
-            <a:ext cx="1371600" cy="274320"/>
+            <a:off x="6766560" y="2514600"/>
+            <a:ext cx="1645920" cy="274320"/>
           </a:xfrm>
           <a:prstGeom prst="rect">
             <a:avLst/>
@@ -11625,7 +11257,7 @@
                 <a:ea typeface="Consolas" pitchFamily="34" charset="-122"/>
                 <a:cs typeface="Consolas" pitchFamily="34" charset="-120"/>
               </a:rPr>
-              <a:t>Gas: Sponsored</a:t>
+              <a:t>Gas: Source</a:t>
             </a:r>
             <a:endParaRPr lang="en-US" sz="900" dirty="0"/>
           </a:p>
@@ -11639,293 +11271,8 @@
         </p:nvSpPr>
         <p:spPr>
           <a:xfrm>
-            <a:off x="5760720" y="3017520"/>
-            <a:ext cx="1371600" cy="914400"/>
-          </a:xfrm>
-          <a:prstGeom prst="rect">
-            <a:avLst/>
-          </a:prstGeom>
-          <a:noFill/>
-          <a:ln/>
-        </p:spPr>
-        <p:txBody>
-          <a:bodyPr wrap="square" lIns="0" tIns="0" rIns="0" bIns="0" rtlCol="0" anchor="ctr"/>
-          <a:lstStyle/>
-          <a:p>
-            <a:pPr indent="0" marL="0">
-              <a:lnSpc>
-                <a:spcPct val="140000"/>
-              </a:lnSpc>
-              <a:buNone/>
-            </a:pPr>
-            <a:r>
-              <a:rPr lang="en-US" sz="1000" dirty="0">
-                <a:solidFill>
-                  <a:srgbClr val="8888A0"/>
-                </a:solidFill>
-                <a:latin typeface="Calibri" pitchFamily="34" charset="0"/>
-                <a:ea typeface="Calibri" pitchFamily="34" charset="-122"/>
-                <a:cs typeface="Calibri" pitchFamily="34" charset="-120"/>
-              </a:rPr>
-              <a:t>Sponsored gas</a:t>
-            </a:r>
-            <a:endParaRPr lang="en-US" sz="1000" dirty="0"/>
-          </a:p>
-          <a:p>
-            <a:pPr indent="0" marL="0">
-              <a:lnSpc>
-                <a:spcPct val="140000"/>
-              </a:lnSpc>
-              <a:buNone/>
-            </a:pPr>
-            <a:r>
-              <a:rPr lang="en-US" sz="1000" dirty="0">
-                <a:solidFill>
-                  <a:srgbClr val="8888A0"/>
-                </a:solidFill>
-                <a:latin typeface="Calibri" pitchFamily="34" charset="0"/>
-                <a:ea typeface="Calibri" pitchFamily="34" charset="-122"/>
-                <a:cs typeface="Calibri" pitchFamily="34" charset="-120"/>
-              </a:rPr>
-              <a:t>Zero-barrier onboarding</a:t>
-            </a:r>
-            <a:endParaRPr lang="en-US" sz="1000" dirty="0"/>
-          </a:p>
-        </p:txBody>
-      </p:sp>
-      <p:sp>
-        <p:nvSpPr>
-          <p:cNvPr id="36" name="Shape 33"/>
-          <p:cNvSpPr/>
-          <p:nvPr/>
-        </p:nvSpPr>
-        <p:spPr>
-          <a:xfrm>
-            <a:off x="7406640" y="1097280"/>
-            <a:ext cx="1645920" cy="3291840"/>
-          </a:xfrm>
-          <a:prstGeom prst="rect">
-            <a:avLst/>
-          </a:prstGeom>
-          <a:solidFill>
-            <a:srgbClr val="151829"/>
-          </a:solidFill>
-          <a:ln/>
-          <a:effectLst>
-            <a:outerShdw sx="100000" sy="100000" kx="0" ky="0" algn="bl" rotWithShape="0" blurRad="101600" dist="38100" dir="8100000">
-              <a:srgbClr val="000000">
-                <a:alpha val="30000"/>
-              </a:srgbClr>
-            </a:outerShdw>
-          </a:effectLst>
-        </p:spPr>
-      </p:sp>
-      <p:sp>
-        <p:nvSpPr>
-          <p:cNvPr id="37" name="Shape 34"/>
-          <p:cNvSpPr/>
-          <p:nvPr/>
-        </p:nvSpPr>
-        <p:spPr>
-          <a:xfrm>
-            <a:off x="7406640" y="1097280"/>
-            <a:ext cx="1645920" cy="45720"/>
-          </a:xfrm>
-          <a:prstGeom prst="rect">
-            <a:avLst/>
-          </a:prstGeom>
-          <a:solidFill>
-            <a:srgbClr val="06B6D4"/>
-          </a:solidFill>
-          <a:ln/>
-        </p:spPr>
-      </p:sp>
-      <p:sp>
-        <p:nvSpPr>
-          <p:cNvPr id="38" name="Text 35"/>
-          <p:cNvSpPr/>
-          <p:nvPr/>
-        </p:nvSpPr>
-        <p:spPr>
-          <a:xfrm>
-            <a:off x="7543800" y="1280160"/>
-            <a:ext cx="1371600" cy="320040"/>
-          </a:xfrm>
-          <a:prstGeom prst="rect">
-            <a:avLst/>
-          </a:prstGeom>
-          <a:noFill/>
-          <a:ln/>
-        </p:spPr>
-        <p:txBody>
-          <a:bodyPr wrap="square" lIns="0" tIns="0" rIns="0" bIns="0" rtlCol="0" anchor="ctr"/>
-          <a:lstStyle/>
-          <a:p>
-            <a:pPr indent="0" marL="0">
-              <a:buNone/>
-            </a:pPr>
-            <a:r>
-              <a:rPr lang="en-US" sz="1300" b="1" dirty="0">
-                <a:solidFill>
-                  <a:srgbClr val="06B6D4"/>
-                </a:solidFill>
-                <a:latin typeface="Arial" pitchFamily="34" charset="0"/>
-                <a:ea typeface="Arial" pitchFamily="34" charset="-122"/>
-                <a:cs typeface="Arial" pitchFamily="34" charset="-120"/>
-              </a:rPr>
-              <a:t>CCTP</a:t>
-            </a:r>
-            <a:endParaRPr lang="en-US" sz="1300" dirty="0"/>
-          </a:p>
-        </p:txBody>
-      </p:sp>
-      <p:sp>
-        <p:nvSpPr>
-          <p:cNvPr id="39" name="Text 36"/>
-          <p:cNvSpPr/>
-          <p:nvPr/>
-        </p:nvSpPr>
-        <p:spPr>
-          <a:xfrm>
-            <a:off x="7543800" y="1737360"/>
-            <a:ext cx="1371600" cy="365760"/>
-          </a:xfrm>
-          <a:prstGeom prst="rect">
-            <a:avLst/>
-          </a:prstGeom>
-          <a:noFill/>
-          <a:ln/>
-        </p:spPr>
-        <p:txBody>
-          <a:bodyPr wrap="square" lIns="0" tIns="0" rIns="0" bIns="0" rtlCol="0" anchor="ctr"/>
-          <a:lstStyle/>
-          <a:p>
-            <a:pPr indent="0" marL="0">
-              <a:buNone/>
-            </a:pPr>
-            <a:r>
-              <a:rPr lang="en-US" sz="2000" dirty="0">
-                <a:solidFill>
-                  <a:srgbClr val="FFFFFF"/>
-                </a:solidFill>
-                <a:latin typeface="Arial Black" pitchFamily="34" charset="0"/>
-                <a:ea typeface="Arial Black" pitchFamily="34" charset="-122"/>
-                <a:cs typeface="Arial Black" pitchFamily="34" charset="-120"/>
-              </a:rPr>
-              <a:t>10-30min</a:t>
-            </a:r>
-            <a:endParaRPr lang="en-US" sz="2000" dirty="0"/>
-          </a:p>
-        </p:txBody>
-      </p:sp>
-      <p:sp>
-        <p:nvSpPr>
-          <p:cNvPr id="40" name="Text 37"/>
-          <p:cNvSpPr/>
-          <p:nvPr/>
-        </p:nvSpPr>
-        <p:spPr>
-          <a:xfrm>
-            <a:off x="7543800" y="2103120"/>
-            <a:ext cx="1371600" cy="228600"/>
-          </a:xfrm>
-          <a:prstGeom prst="rect">
-            <a:avLst/>
-          </a:prstGeom>
-          <a:noFill/>
-          <a:ln/>
-        </p:spPr>
-        <p:txBody>
-          <a:bodyPr wrap="square" lIns="0" tIns="0" rIns="0" bIns="0" rtlCol="0" anchor="ctr"/>
-          <a:lstStyle/>
-          <a:p>
-            <a:pPr indent="0" marL="0">
-              <a:buNone/>
-            </a:pPr>
-            <a:r>
-              <a:rPr lang="en-US" sz="900" dirty="0">
-                <a:solidFill>
-                  <a:srgbClr val="8888A0"/>
-                </a:solidFill>
-                <a:latin typeface="Calibri" pitchFamily="34" charset="0"/>
-                <a:ea typeface="Calibri" pitchFamily="34" charset="-122"/>
-                <a:cs typeface="Calibri" pitchFamily="34" charset="-120"/>
-              </a:rPr>
-              <a:t>Latency</a:t>
-            </a:r>
-            <a:endParaRPr lang="en-US" sz="900" dirty="0"/>
-          </a:p>
-        </p:txBody>
-      </p:sp>
-      <p:sp>
-        <p:nvSpPr>
-          <p:cNvPr id="41" name="Shape 38"/>
-          <p:cNvSpPr/>
-          <p:nvPr/>
-        </p:nvSpPr>
-        <p:spPr>
-          <a:xfrm>
-            <a:off x="7543800" y="2514600"/>
-            <a:ext cx="1371600" cy="274320"/>
-          </a:xfrm>
-          <a:prstGeom prst="rect">
-            <a:avLst/>
-          </a:prstGeom>
-          <a:solidFill>
-            <a:srgbClr val="1C2039"/>
-          </a:solidFill>
-          <a:ln/>
-        </p:spPr>
-      </p:sp>
-      <p:sp>
-        <p:nvSpPr>
-          <p:cNvPr id="42" name="Text 39"/>
-          <p:cNvSpPr/>
-          <p:nvPr/>
-        </p:nvSpPr>
-        <p:spPr>
-          <a:xfrm>
-            <a:off x="7543800" y="2514600"/>
-            <a:ext cx="1371600" cy="274320"/>
-          </a:xfrm>
-          <a:prstGeom prst="rect">
-            <a:avLst/>
-          </a:prstGeom>
-          <a:noFill/>
-          <a:ln/>
-        </p:spPr>
-        <p:txBody>
-          <a:bodyPr wrap="square" lIns="0" tIns="0" rIns="0" bIns="0" rtlCol="0" anchor="ctr"/>
-          <a:lstStyle/>
-          <a:p>
-            <a:pPr algn="ctr" indent="0" marL="0">
-              <a:buNone/>
-            </a:pPr>
-            <a:r>
-              <a:rPr lang="en-US" sz="900" dirty="0">
-                <a:solidFill>
-                  <a:srgbClr val="C4C4D4"/>
-                </a:solidFill>
-                <a:latin typeface="Consolas" pitchFamily="34" charset="0"/>
-                <a:ea typeface="Consolas" pitchFamily="34" charset="-122"/>
-                <a:cs typeface="Consolas" pitchFamily="34" charset="-120"/>
-              </a:rPr>
-              <a:t>Gas: Source</a:t>
-            </a:r>
-            <a:endParaRPr lang="en-US" sz="900" dirty="0"/>
-          </a:p>
-        </p:txBody>
-      </p:sp>
-      <p:sp>
-        <p:nvSpPr>
-          <p:cNvPr id="43" name="Text 40"/>
-          <p:cNvSpPr/>
-          <p:nvPr/>
-        </p:nvSpPr>
-        <p:spPr>
-          <a:xfrm>
-            <a:off x="7543800" y="3017520"/>
-            <a:ext cx="1371600" cy="914400"/>
+            <a:off x="6766560" y="3017520"/>
+            <a:ext cx="1645920" cy="914400"/>
           </a:xfrm>
           <a:prstGeom prst="rect">
             <a:avLst/>
@@ -14747,7 +14094,7 @@
         <p:spPr>
           <a:xfrm>
             <a:off x="1234440" y="320040"/>
-            <a:ext cx="7315200" cy="411480"/>
+            <a:ext cx="6400800" cy="411480"/>
           </a:xfrm>
           <a:prstGeom prst="rect">
             <a:avLst/>
@@ -14763,7 +14110,7 @@
               <a:buNone/>
             </a:pPr>
             <a:r>
-              <a:rPr lang="en-US" sz="2000" dirty="0">
+              <a:rPr lang="en-US" sz="2400" dirty="0">
                 <a:solidFill>
                   <a:srgbClr val="FFFFFF"/>
                 </a:solidFill>
@@ -14771,9 +14118,9 @@
                 <a:ea typeface="Arial Black" pitchFamily="34" charset="-122"/>
                 <a:cs typeface="Arial Black" pitchFamily="34" charset="-120"/>
               </a:rPr>
-              <a:t>MagicBlock High-Frequency Payment Channels</a:t>
-            </a:r>
-            <a:endParaRPr lang="en-US" sz="2000" dirty="0"/>
+              <a:t>Future Roadmap</a:t>
+            </a:r>
+            <a:endParaRPr lang="en-US" sz="2400" dirty="0"/>
           </a:p>
         </p:txBody>
       </p:sp>
@@ -14785,8 +14132,76 @@
         </p:nvSpPr>
         <p:spPr>
           <a:xfrm>
-            <a:off x="457200" y="1188720"/>
-            <a:ext cx="4114800" cy="731520"/>
+            <a:off x="6400800" y="365760"/>
+            <a:ext cx="2286000" cy="320040"/>
+          </a:xfrm>
+          <a:prstGeom prst="rect">
+            <a:avLst>
+              <a:gd name="adj" fmla="val 14286"/>
+            </a:avLst>
+          </a:prstGeom>
+          <a:solidFill>
+            <a:srgbClr val="9945FF">
+              <a:alpha val="30000"/>
+            </a:srgbClr>
+          </a:solidFill>
+          <a:ln w="12700">
+            <a:solidFill>
+              <a:srgbClr val="9945FF"/>
+            </a:solidFill>
+            <a:prstDash val="solid"/>
+          </a:ln>
+        </p:spPr>
+      </p:sp>
+      <p:sp>
+        <p:nvSpPr>
+          <p:cNvPr id="5" name="Text 2"/>
+          <p:cNvSpPr/>
+          <p:nvPr/>
+        </p:nvSpPr>
+        <p:spPr>
+          <a:xfrm>
+            <a:off x="6400800" y="365760"/>
+            <a:ext cx="2286000" cy="320040"/>
+          </a:xfrm>
+          <a:prstGeom prst="rect">
+            <a:avLst/>
+          </a:prstGeom>
+          <a:noFill/>
+          <a:ln/>
+        </p:spPr>
+        <p:txBody>
+          <a:bodyPr wrap="square" lIns="0" tIns="0" rIns="0" bIns="0" rtlCol="0" anchor="ctr"/>
+          <a:lstStyle/>
+          <a:p>
+            <a:pPr algn="ctr" indent="0" marL="0">
+              <a:buNone/>
+            </a:pPr>
+            <a:r>
+              <a:rPr lang="en-US" sz="1000" dirty="0">
+                <a:solidFill>
+                  <a:srgbClr val="D4A0FF"/>
+                </a:solidFill>
+                <a:latin typeface="Consolas" pitchFamily="34" charset="0"/>
+                <a:ea typeface="Consolas" pitchFamily="34" charset="-122"/>
+                <a:cs typeface="Consolas" pitchFamily="34" charset="-120"/>
+              </a:rPr>
+              <a:t>ROADMAP</a:t>
+            </a:r>
+            <a:endParaRPr lang="en-US" sz="1000" dirty="0"/>
+          </a:p>
+        </p:txBody>
+      </p:sp>
+      <p:sp>
+        <p:nvSpPr>
+          <p:cNvPr id="6" name="Shape 3"/>
+          <p:cNvSpPr/>
+          <p:nvPr/>
+        </p:nvSpPr>
+        <p:spPr>
+          <a:xfrm>
+            <a:off x="457200" y="1097280"/>
+            <a:ext cx="3931920" cy="3474720"/>
           </a:xfrm>
           <a:prstGeom prst="rect">
             <a:avLst/>
@@ -14806,34 +14221,34 @@
       </p:sp>
       <p:sp>
         <p:nvSpPr>
-          <p:cNvPr id="5" name="Shape 2"/>
-          <p:cNvSpPr/>
-          <p:nvPr/>
-        </p:nvSpPr>
-        <p:spPr>
-          <a:xfrm>
-            <a:off x="457200" y="1188720"/>
-            <a:ext cx="73152" cy="731520"/>
+          <p:cNvPr id="7" name="Shape 4"/>
+          <p:cNvSpPr/>
+          <p:nvPr/>
+        </p:nvSpPr>
+        <p:spPr>
+          <a:xfrm>
+            <a:off x="457200" y="1097280"/>
+            <a:ext cx="3931920" cy="54864"/>
           </a:xfrm>
           <a:prstGeom prst="rect">
             <a:avLst/>
           </a:prstGeom>
           <a:solidFill>
-            <a:srgbClr val="9945FF"/>
+            <a:srgbClr val="14F195"/>
           </a:solidFill>
           <a:ln/>
         </p:spPr>
       </p:sp>
       <p:sp>
         <p:nvSpPr>
-          <p:cNvPr id="6" name="Text 3"/>
-          <p:cNvSpPr/>
-          <p:nvPr/>
-        </p:nvSpPr>
-        <p:spPr>
-          <a:xfrm>
-            <a:off x="731520" y="1188720"/>
-            <a:ext cx="1645920" cy="731520"/>
+          <p:cNvPr id="8" name="Text 5"/>
+          <p:cNvSpPr/>
+          <p:nvPr/>
+        </p:nvSpPr>
+        <p:spPr>
+          <a:xfrm>
+            <a:off x="731520" y="1325880"/>
+            <a:ext cx="3383280" cy="320040"/>
           </a:xfrm>
           <a:prstGeom prst="rect">
             <a:avLst/>
@@ -14849,92 +14264,175 @@
               <a:buNone/>
             </a:pPr>
             <a:r>
-              <a:rPr lang="en-US" sz="1300" b="1" dirty="0">
-                <a:solidFill>
-                  <a:srgbClr val="9945FF"/>
+              <a:rPr lang="en-US" sz="1500" b="1" dirty="0">
+                <a:solidFill>
+                  <a:srgbClr val="14F195"/>
                 </a:solidFill>
                 <a:latin typeface="Arial" pitchFamily="34" charset="0"/>
                 <a:ea typeface="Arial" pitchFamily="34" charset="-122"/>
                 <a:cs typeface="Arial" pitchFamily="34" charset="-120"/>
               </a:rPr>
-              <a:t>L1 Solana</a:t>
-            </a:r>
-            <a:endParaRPr lang="en-US" sz="1300" dirty="0"/>
-          </a:p>
-        </p:txBody>
-      </p:sp>
-      <p:sp>
-        <p:nvSpPr>
-          <p:cNvPr id="7" name="Text 4"/>
-          <p:cNvSpPr/>
-          <p:nvPr/>
-        </p:nvSpPr>
-        <p:spPr>
-          <a:xfrm>
-            <a:off x="2377440" y="1188720"/>
-            <a:ext cx="2103120" cy="731520"/>
-          </a:xfrm>
-          <a:prstGeom prst="rect">
-            <a:avLst/>
-          </a:prstGeom>
-          <a:noFill/>
-          <a:ln/>
-        </p:spPr>
-        <p:txBody>
-          <a:bodyPr wrap="square" lIns="0" tIns="0" rIns="0" bIns="0" rtlCol="0" anchor="ctr"/>
-          <a:lstStyle/>
-          <a:p>
-            <a:pPr indent="0" marL="0">
-              <a:lnSpc>
-                <a:spcPct val="130000"/>
-              </a:lnSpc>
-              <a:buNone/>
-            </a:pPr>
-            <a:r>
-              <a:rPr lang="en-US" sz="1000" dirty="0">
-                <a:solidFill>
-                  <a:srgbClr val="C4C4D4"/>
+              <a:t>MagicBlock High-Freq Channels</a:t>
+            </a:r>
+            <a:endParaRPr lang="en-US" sz="1500" dirty="0"/>
+          </a:p>
+        </p:txBody>
+      </p:sp>
+      <p:sp>
+        <p:nvSpPr>
+          <p:cNvPr id="9" name="Text 6"/>
+          <p:cNvSpPr/>
+          <p:nvPr/>
+        </p:nvSpPr>
+        <p:spPr>
+          <a:xfrm>
+            <a:off x="731520" y="1828800"/>
+            <a:ext cx="3383280" cy="1371600"/>
+          </a:xfrm>
+          <a:prstGeom prst="rect">
+            <a:avLst/>
+          </a:prstGeom>
+          <a:noFill/>
+          <a:ln/>
+        </p:spPr>
+        <p:txBody>
+          <a:bodyPr wrap="square" lIns="0" tIns="0" rIns="0" bIns="0" rtlCol="0" anchor="ctr"/>
+          <a:lstStyle/>
+          <a:p>
+            <a:pPr marL="342900" indent="-342900">
+              <a:spcAft>
+                <a:spcPts val="800"/>
+              </a:spcAft>
+              <a:buSzPct val="100000"/>
+              <a:buChar char="•"/>
+            </a:pPr>
+            <a:r>
+              <a:rPr lang="en-US" sz="1100" dirty="0">
+                <a:solidFill>
+                  <a:srgbClr val="FFFFFF"/>
                 </a:solidFill>
                 <a:latin typeface="Calibri" pitchFamily="34" charset="0"/>
                 <a:ea typeface="Calibri" pitchFamily="34" charset="-122"/>
                 <a:cs typeface="Calibri" pitchFamily="34" charset="-120"/>
               </a:rPr>
-              <a:t>Channel creation / fund locking</a:t>
-            </a:r>
-            <a:endParaRPr lang="en-US" sz="1000" dirty="0"/>
-          </a:p>
-          <a:p>
-            <a:pPr indent="0" marL="0">
-              <a:lnSpc>
-                <a:spcPct val="130000"/>
-              </a:lnSpc>
-              <a:buNone/>
-            </a:pPr>
-            <a:r>
-              <a:rPr lang="en-US" sz="1000" dirty="0">
-                <a:solidFill>
-                  <a:srgbClr val="C4C4D4"/>
+              <a:t>Off-chain Voucher signing, sub-second payments</a:t>
+            </a:r>
+            <a:endParaRPr lang="en-US" sz="1100" dirty="0"/>
+          </a:p>
+          <a:p>
+            <a:pPr marL="342900" indent="-342900">
+              <a:spcAft>
+                <a:spcPts val="800"/>
+              </a:spcAft>
+              <a:buSzPct val="100000"/>
+              <a:buChar char="•"/>
+            </a:pPr>
+            <a:r>
+              <a:rPr lang="en-US" sz="1100" dirty="0">
+                <a:solidFill>
+                  <a:srgbClr val="FFFFFF"/>
                 </a:solidFill>
                 <a:latin typeface="Calibri" pitchFamily="34" charset="0"/>
                 <a:ea typeface="Calibri" pitchFamily="34" charset="-122"/>
                 <a:cs typeface="Calibri" pitchFamily="34" charset="-120"/>
               </a:rPr>
-              <a:t>Signature verification / batch settlement</a:t>
-            </a:r>
-            <a:endParaRPr lang="en-US" sz="1000" dirty="0"/>
-          </a:p>
-        </p:txBody>
-      </p:sp>
-      <p:sp>
-        <p:nvSpPr>
-          <p:cNvPr id="8" name="Shape 5"/>
-          <p:cNvSpPr/>
-          <p:nvPr/>
-        </p:nvSpPr>
-        <p:spPr>
-          <a:xfrm>
-            <a:off x="457200" y="2103120"/>
-            <a:ext cx="4114800" cy="731520"/>
+              <a:t>3-tier: L1 Solana + MagicBlock ER + Off-chain</a:t>
+            </a:r>
+            <a:endParaRPr lang="en-US" sz="1100" dirty="0"/>
+          </a:p>
+          <a:p>
+            <a:pPr marL="342900" indent="-342900">
+              <a:spcAft>
+                <a:spcPts val="800"/>
+              </a:spcAft>
+              <a:buSzPct val="100000"/>
+              <a:buChar char="•"/>
+            </a:pPr>
+            <a:r>
+              <a:rPr lang="en-US" sz="1100" dirty="0">
+                <a:solidFill>
+                  <a:srgbClr val="FFFFFF"/>
+                </a:solidFill>
+                <a:latin typeface="Calibri" pitchFamily="34" charset="0"/>
+                <a:ea typeface="Calibri" pitchFamily="34" charset="-122"/>
+                <a:cs typeface="Calibri" pitchFamily="34" charset="-120"/>
+              </a:rPr>
+              <a:t>Sum-Merkle Tree batch settlement in one tx</a:t>
+            </a:r>
+            <a:endParaRPr lang="en-US" sz="1100" dirty="0"/>
+          </a:p>
+          <a:p>
+            <a:pPr marL="342900" indent="-342900">
+              <a:spcAft>
+                <a:spcPts val="800"/>
+              </a:spcAft>
+              <a:buSzPct val="100000"/>
+              <a:buChar char="•"/>
+            </a:pPr>
+            <a:r>
+              <a:rPr lang="en-US" sz="1100" dirty="0">
+                <a:solidFill>
+                  <a:srgbClr val="FFFFFF"/>
+                </a:solidFill>
+                <a:latin typeface="Calibri" pitchFamily="34" charset="0"/>
+                <a:ea typeface="Calibri" pitchFamily="34" charset="-122"/>
+                <a:cs typeface="Calibri" pitchFamily="34" charset="-120"/>
+              </a:rPr>
+              <a:t>Gas-free, &lt;50ms latency</a:t>
+            </a:r>
+            <a:endParaRPr lang="en-US" sz="1100" dirty="0"/>
+          </a:p>
+        </p:txBody>
+      </p:sp>
+      <p:sp>
+        <p:nvSpPr>
+          <p:cNvPr id="10" name="Text 7"/>
+          <p:cNvSpPr/>
+          <p:nvPr/>
+        </p:nvSpPr>
+        <p:spPr>
+          <a:xfrm>
+            <a:off x="731520" y="3474720"/>
+            <a:ext cx="3383280" cy="274320"/>
+          </a:xfrm>
+          <a:prstGeom prst="rect">
+            <a:avLst/>
+          </a:prstGeom>
+          <a:noFill/>
+          <a:ln/>
+        </p:spPr>
+        <p:txBody>
+          <a:bodyPr wrap="square" lIns="0" tIns="0" rIns="0" bIns="0" rtlCol="0" anchor="ctr"/>
+          <a:lstStyle/>
+          <a:p>
+            <a:pPr indent="0" marL="0">
+              <a:buNone/>
+            </a:pPr>
+            <a:r>
+              <a:rPr lang="en-US" sz="900" dirty="0">
+                <a:solidFill>
+                  <a:srgbClr val="8888A0"/>
+                </a:solidFill>
+                <a:latin typeface="Calibri" pitchFamily="34" charset="0"/>
+                <a:ea typeface="Calibri" pitchFamily="34" charset="-122"/>
+                <a:cs typeface="Calibri" pitchFamily="34" charset="-120"/>
+              </a:rPr>
+              <a:t>Use cases: high-freq micro-payments, API billing, vending</a:t>
+            </a:r>
+            <a:endParaRPr lang="en-US" sz="900" dirty="0"/>
+          </a:p>
+        </p:txBody>
+      </p:sp>
+      <p:sp>
+        <p:nvSpPr>
+          <p:cNvPr id="11" name="Shape 8"/>
+          <p:cNvSpPr/>
+          <p:nvPr/>
+        </p:nvSpPr>
+        <p:spPr>
+          <a:xfrm>
+            <a:off x="4754880" y="1097280"/>
+            <a:ext cx="3931920" cy="3474720"/>
           </a:xfrm>
           <a:prstGeom prst="rect">
             <a:avLst/>
@@ -14954,34 +14452,34 @@
       </p:sp>
       <p:sp>
         <p:nvSpPr>
-          <p:cNvPr id="9" name="Shape 6"/>
-          <p:cNvSpPr/>
-          <p:nvPr/>
-        </p:nvSpPr>
-        <p:spPr>
-          <a:xfrm>
-            <a:off x="457200" y="2103120"/>
-            <a:ext cx="73152" cy="731520"/>
+          <p:cNvPr id="12" name="Shape 9"/>
+          <p:cNvSpPr/>
+          <p:nvPr/>
+        </p:nvSpPr>
+        <p:spPr>
+          <a:xfrm>
+            <a:off x="4754880" y="1097280"/>
+            <a:ext cx="3931920" cy="54864"/>
           </a:xfrm>
           <a:prstGeom prst="rect">
             <a:avLst/>
           </a:prstGeom>
           <a:solidFill>
-            <a:srgbClr val="14F195"/>
+            <a:srgbClr val="9945FF"/>
           </a:solidFill>
           <a:ln/>
         </p:spPr>
       </p:sp>
       <p:sp>
         <p:nvSpPr>
-          <p:cNvPr id="10" name="Text 7"/>
-          <p:cNvSpPr/>
-          <p:nvPr/>
-        </p:nvSpPr>
-        <p:spPr>
-          <a:xfrm>
-            <a:off x="731520" y="2103120"/>
-            <a:ext cx="1645920" cy="731520"/>
+          <p:cNvPr id="13" name="Text 10"/>
+          <p:cNvSpPr/>
+          <p:nvPr/>
+        </p:nvSpPr>
+        <p:spPr>
+          <a:xfrm>
+            <a:off x="5029200" y="1325880"/>
+            <a:ext cx="3383280" cy="320040"/>
           </a:xfrm>
           <a:prstGeom prst="rect">
             <a:avLst/>
@@ -14997,260 +14495,136 @@
               <a:buNone/>
             </a:pPr>
             <a:r>
-              <a:rPr lang="en-US" sz="1300" b="1" dirty="0">
-                <a:solidFill>
-                  <a:srgbClr val="14F195"/>
+              <a:rPr lang="en-US" sz="1500" b="1" dirty="0">
+                <a:solidFill>
+                  <a:srgbClr val="D4A0FF"/>
                 </a:solidFill>
                 <a:latin typeface="Arial" pitchFamily="34" charset="0"/>
                 <a:ea typeface="Arial" pitchFamily="34" charset="-122"/>
                 <a:cs typeface="Arial" pitchFamily="34" charset="-120"/>
               </a:rPr>
-              <a:t>MagicBlock ER</a:t>
-            </a:r>
-            <a:endParaRPr lang="en-US" sz="1300" dirty="0"/>
-          </a:p>
-        </p:txBody>
-      </p:sp>
-      <p:sp>
-        <p:nvSpPr>
-          <p:cNvPr id="11" name="Text 8"/>
-          <p:cNvSpPr/>
-          <p:nvPr/>
-        </p:nvSpPr>
-        <p:spPr>
-          <a:xfrm>
-            <a:off x="2377440" y="2103120"/>
-            <a:ext cx="2103120" cy="731520"/>
-          </a:xfrm>
-          <a:prstGeom prst="rect">
-            <a:avLst/>
-          </a:prstGeom>
-          <a:noFill/>
-          <a:ln/>
-        </p:spPr>
-        <p:txBody>
-          <a:bodyPr wrap="square" lIns="0" tIns="0" rIns="0" bIns="0" rtlCol="0" anchor="ctr"/>
-          <a:lstStyle/>
-          <a:p>
-            <a:pPr indent="0" marL="0">
-              <a:lnSpc>
-                <a:spcPct val="130000"/>
-              </a:lnSpc>
-              <a:buNone/>
-            </a:pPr>
-            <a:r>
-              <a:rPr lang="en-US" sz="1000" dirty="0">
-                <a:solidFill>
-                  <a:srgbClr val="C4C4D4"/>
+              <a:t>ZK Compression DID Registry</a:t>
+            </a:r>
+            <a:endParaRPr lang="en-US" sz="1500" dirty="0"/>
+          </a:p>
+        </p:txBody>
+      </p:sp>
+      <p:sp>
+        <p:nvSpPr>
+          <p:cNvPr id="14" name="Text 11"/>
+          <p:cNvSpPr/>
+          <p:nvPr/>
+        </p:nvSpPr>
+        <p:spPr>
+          <a:xfrm>
+            <a:off x="5029200" y="1828800"/>
+            <a:ext cx="3383280" cy="1371600"/>
+          </a:xfrm>
+          <a:prstGeom prst="rect">
+            <a:avLst/>
+          </a:prstGeom>
+          <a:noFill/>
+          <a:ln/>
+        </p:spPr>
+        <p:txBody>
+          <a:bodyPr wrap="square" lIns="0" tIns="0" rIns="0" bIns="0" rtlCol="0" anchor="ctr"/>
+          <a:lstStyle/>
+          <a:p>
+            <a:pPr marL="342900" indent="-342900">
+              <a:spcAft>
+                <a:spcPts val="800"/>
+              </a:spcAft>
+              <a:buSzPct val="100000"/>
+              <a:buChar char="•"/>
+            </a:pPr>
+            <a:r>
+              <a:rPr lang="en-US" sz="1100" dirty="0">
+                <a:solidFill>
+                  <a:srgbClr val="FFFFFF"/>
                 </a:solidFill>
                 <a:latin typeface="Calibri" pitchFamily="34" charset="0"/>
                 <a:ea typeface="Calibri" pitchFamily="34" charset="-122"/>
                 <a:cs typeface="Calibri" pitchFamily="34" charset="-120"/>
               </a:rPr>
-              <a:t>High-speed state transition (&lt;50ms)</a:t>
-            </a:r>
-            <a:endParaRPr lang="en-US" sz="1000" dirty="0"/>
-          </a:p>
-          <a:p>
-            <a:pPr indent="0" marL="0">
-              <a:lnSpc>
-                <a:spcPct val="130000"/>
-              </a:lnSpc>
-              <a:buNone/>
-            </a:pPr>
-            <a:r>
-              <a:rPr lang="en-US" sz="1000" dirty="0">
-                <a:solidFill>
-                  <a:srgbClr val="C4C4D4"/>
+              <a:t>ZK Compression-based on-chain DID storage</a:t>
+            </a:r>
+            <a:endParaRPr lang="en-US" sz="1100" dirty="0"/>
+          </a:p>
+          <a:p>
+            <a:pPr marL="342900" indent="-342900">
+              <a:spcAft>
+                <a:spcPts val="800"/>
+              </a:spcAft>
+              <a:buSzPct val="100000"/>
+              <a:buChar char="•"/>
+            </a:pPr>
+            <a:r>
+              <a:rPr lang="en-US" sz="1100" dirty="0">
+                <a:solidFill>
+                  <a:srgbClr val="FFFFFF"/>
                 </a:solidFill>
                 <a:latin typeface="Calibri" pitchFamily="34" charset="0"/>
                 <a:ea typeface="Calibri" pitchFamily="34" charset="-122"/>
                 <a:cs typeface="Calibri" pitchFamily="34" charset="-120"/>
               </a:rPr>
-              <a:t>Gas-free / real-time Voucher recording</a:t>
-            </a:r>
-            <a:endParaRPr lang="en-US" sz="1000" dirty="0"/>
-          </a:p>
-        </p:txBody>
-      </p:sp>
-      <p:sp>
-        <p:nvSpPr>
-          <p:cNvPr id="12" name="Shape 9"/>
-          <p:cNvSpPr/>
-          <p:nvPr/>
-        </p:nvSpPr>
-        <p:spPr>
-          <a:xfrm>
-            <a:off x="457200" y="3017520"/>
-            <a:ext cx="4114800" cy="731520"/>
-          </a:xfrm>
-          <a:prstGeom prst="rect">
-            <a:avLst/>
-          </a:prstGeom>
-          <a:solidFill>
-            <a:srgbClr val="151829"/>
-          </a:solidFill>
-          <a:ln/>
-          <a:effectLst>
-            <a:outerShdw sx="100000" sy="100000" kx="0" ky="0" algn="bl" rotWithShape="0" blurRad="101600" dist="38100" dir="8100000">
-              <a:srgbClr val="000000">
-                <a:alpha val="30000"/>
-              </a:srgbClr>
-            </a:outerShdw>
-          </a:effectLst>
-        </p:spPr>
-      </p:sp>
-      <p:sp>
-        <p:nvSpPr>
-          <p:cNvPr id="13" name="Shape 10"/>
-          <p:cNvSpPr/>
-          <p:nvPr/>
-        </p:nvSpPr>
-        <p:spPr>
-          <a:xfrm>
-            <a:off x="457200" y="3017520"/>
-            <a:ext cx="73152" cy="731520"/>
-          </a:xfrm>
-          <a:prstGeom prst="rect">
-            <a:avLst/>
-          </a:prstGeom>
-          <a:solidFill>
-            <a:srgbClr val="F59E0B"/>
-          </a:solidFill>
-          <a:ln/>
-        </p:spPr>
-      </p:sp>
-      <p:sp>
-        <p:nvSpPr>
-          <p:cNvPr id="14" name="Text 11"/>
-          <p:cNvSpPr/>
-          <p:nvPr/>
-        </p:nvSpPr>
-        <p:spPr>
-          <a:xfrm>
-            <a:off x="731520" y="3017520"/>
-            <a:ext cx="1645920" cy="731520"/>
-          </a:xfrm>
-          <a:prstGeom prst="rect">
-            <a:avLst/>
-          </a:prstGeom>
-          <a:noFill/>
-          <a:ln/>
-        </p:spPr>
-        <p:txBody>
-          <a:bodyPr wrap="square" lIns="0" tIns="0" rIns="0" bIns="0" rtlCol="0" anchor="ctr"/>
-          <a:lstStyle/>
-          <a:p>
-            <a:pPr indent="0" marL="0">
-              <a:buNone/>
-            </a:pPr>
-            <a:r>
-              <a:rPr lang="en-US" sz="1300" b="1" dirty="0">
-                <a:solidFill>
-                  <a:srgbClr val="F59E0B"/>
-                </a:solidFill>
-                <a:latin typeface="Arial" pitchFamily="34" charset="0"/>
-                <a:ea typeface="Arial" pitchFamily="34" charset="-122"/>
-                <a:cs typeface="Arial" pitchFamily="34" charset="-120"/>
-              </a:rPr>
-              <a:t>Off-chain</a:t>
-            </a:r>
-            <a:endParaRPr lang="en-US" sz="1300" dirty="0"/>
-          </a:p>
-        </p:txBody>
-      </p:sp>
-      <p:sp>
-        <p:nvSpPr>
-          <p:cNvPr id="15" name="Text 12"/>
-          <p:cNvSpPr/>
-          <p:nvPr/>
-        </p:nvSpPr>
-        <p:spPr>
-          <a:xfrm>
-            <a:off x="2377440" y="3017520"/>
-            <a:ext cx="2103120" cy="731520"/>
-          </a:xfrm>
-          <a:prstGeom prst="rect">
-            <a:avLst/>
-          </a:prstGeom>
-          <a:noFill/>
-          <a:ln/>
-        </p:spPr>
-        <p:txBody>
-          <a:bodyPr wrap="square" lIns="0" tIns="0" rIns="0" bIns="0" rtlCol="0" anchor="ctr"/>
-          <a:lstStyle/>
-          <a:p>
-            <a:pPr indent="0" marL="0">
-              <a:lnSpc>
-                <a:spcPct val="130000"/>
-              </a:lnSpc>
-              <a:buNone/>
-            </a:pPr>
-            <a:r>
-              <a:rPr lang="en-US" sz="1000" dirty="0">
-                <a:solidFill>
-                  <a:srgbClr val="C4C4D4"/>
+              <a:t>Dramatically reduces on-chain storage costs</a:t>
+            </a:r>
+            <a:endParaRPr lang="en-US" sz="1100" dirty="0"/>
+          </a:p>
+          <a:p>
+            <a:pPr marL="342900" indent="-342900">
+              <a:spcAft>
+                <a:spcPts val="800"/>
+              </a:spcAft>
+              <a:buSzPct val="100000"/>
+              <a:buChar char="•"/>
+            </a:pPr>
+            <a:r>
+              <a:rPr lang="en-US" sz="1100" dirty="0">
+                <a:solidFill>
+                  <a:srgbClr val="FFFFFF"/>
                 </a:solidFill>
                 <a:latin typeface="Calibri" pitchFamily="34" charset="0"/>
                 <a:ea typeface="Calibri" pitchFamily="34" charset="-122"/>
                 <a:cs typeface="Calibri" pitchFamily="34" charset="-120"/>
               </a:rPr>
-              <a:t>Dispute window / challenge mechanism</a:t>
-            </a:r>
-            <a:endParaRPr lang="en-US" sz="1000" dirty="0"/>
-          </a:p>
-          <a:p>
-            <a:pPr indent="0" marL="0">
-              <a:lnSpc>
-                <a:spcPct val="130000"/>
-              </a:lnSpc>
-              <a:buNone/>
-            </a:pPr>
-            <a:r>
-              <a:rPr lang="en-US" sz="1000" dirty="0">
-                <a:solidFill>
-                  <a:srgbClr val="C4C4D4"/>
+              <a:t>Supports massive-scale DID identity registration</a:t>
+            </a:r>
+            <a:endParaRPr lang="en-US" sz="1100" dirty="0"/>
+          </a:p>
+          <a:p>
+            <a:pPr marL="342900" indent="-342900">
+              <a:spcAft>
+                <a:spcPts val="800"/>
+              </a:spcAft>
+              <a:buSzPct val="100000"/>
+              <a:buChar char="•"/>
+            </a:pPr>
+            <a:r>
+              <a:rPr lang="en-US" sz="1100" dirty="0">
+                <a:solidFill>
+                  <a:srgbClr val="FFFFFF"/>
                 </a:solidFill>
                 <a:latin typeface="Calibri" pitchFamily="34" charset="0"/>
                 <a:ea typeface="Calibri" pitchFamily="34" charset="-122"/>
                 <a:cs typeface="Calibri" pitchFamily="34" charset="-120"/>
               </a:rPr>
-              <a:t>Sum-Merkle Proof fraud proofs</a:t>
-            </a:r>
-            <a:endParaRPr lang="en-US" sz="1000" dirty="0"/>
-          </a:p>
-        </p:txBody>
-      </p:sp>
-      <p:sp>
-        <p:nvSpPr>
-          <p:cNvPr id="16" name="Shape 13"/>
-          <p:cNvSpPr/>
-          <p:nvPr/>
-        </p:nvSpPr>
-        <p:spPr>
-          <a:xfrm>
-            <a:off x="5029200" y="1188720"/>
-            <a:ext cx="3657600" cy="731520"/>
-          </a:xfrm>
-          <a:prstGeom prst="rect">
-            <a:avLst/>
-          </a:prstGeom>
-          <a:solidFill>
-            <a:srgbClr val="151829"/>
-          </a:solidFill>
-          <a:ln/>
-        </p:spPr>
-      </p:sp>
-      <p:sp>
-        <p:nvSpPr>
-          <p:cNvPr id="17" name="Text 14"/>
-          <p:cNvSpPr/>
-          <p:nvPr/>
-        </p:nvSpPr>
-        <p:spPr>
-          <a:xfrm>
-            <a:off x="5303520" y="1188720"/>
-            <a:ext cx="1645920" cy="731520"/>
+              <a:t>Maintains Solana on-chain verification security</a:t>
+            </a:r>
+            <a:endParaRPr lang="en-US" sz="1100" dirty="0"/>
+          </a:p>
+        </p:txBody>
+      </p:sp>
+      <p:sp>
+        <p:nvSpPr>
+          <p:cNvPr id="15" name="Text 12"/>
+          <p:cNvSpPr/>
+          <p:nvPr/>
+        </p:nvSpPr>
+        <p:spPr>
+          <a:xfrm>
+            <a:off x="5029200" y="3474720"/>
+            <a:ext cx="3383280" cy="274320"/>
           </a:xfrm>
           <a:prstGeom prst="rect">
             <a:avLst/>
@@ -15266,265 +14640,30 @@
               <a:buNone/>
             </a:pPr>
             <a:r>
-              <a:rPr lang="en-US" sz="2400" dirty="0">
-                <a:solidFill>
-                  <a:srgbClr val="14F195"/>
-                </a:solidFill>
-                <a:latin typeface="Arial Black" pitchFamily="34" charset="0"/>
-                <a:ea typeface="Arial Black" pitchFamily="34" charset="-122"/>
-                <a:cs typeface="Arial Black" pitchFamily="34" charset="-120"/>
-              </a:rPr>
-              <a:t>&lt;50ms</a:t>
-            </a:r>
-            <a:endParaRPr lang="en-US" sz="2400" dirty="0"/>
-          </a:p>
-        </p:txBody>
-      </p:sp>
-      <p:sp>
-        <p:nvSpPr>
-          <p:cNvPr id="18" name="Text 15"/>
-          <p:cNvSpPr/>
-          <p:nvPr/>
-        </p:nvSpPr>
-        <p:spPr>
-          <a:xfrm>
-            <a:off x="6949440" y="1188720"/>
-            <a:ext cx="1645920" cy="731520"/>
-          </a:xfrm>
-          <a:prstGeom prst="rect">
-            <a:avLst/>
-          </a:prstGeom>
-          <a:noFill/>
-          <a:ln/>
-        </p:spPr>
-        <p:txBody>
-          <a:bodyPr wrap="square" lIns="0" tIns="0" rIns="0" bIns="0" rtlCol="0" anchor="ctr"/>
-          <a:lstStyle/>
-          <a:p>
-            <a:pPr indent="0" marL="0">
-              <a:buNone/>
-            </a:pPr>
-            <a:r>
-              <a:rPr lang="en-US" sz="1200" dirty="0">
-                <a:solidFill>
-                  <a:srgbClr val="C4C4D4"/>
+              <a:rPr lang="en-US" sz="900" dirty="0">
+                <a:solidFill>
+                  <a:srgbClr val="8888A0"/>
                 </a:solidFill>
                 <a:latin typeface="Calibri" pitchFamily="34" charset="0"/>
                 <a:ea typeface="Calibri" pitchFamily="34" charset="-122"/>
                 <a:cs typeface="Calibri" pitchFamily="34" charset="-120"/>
               </a:rPr>
-              <a:t>Payment Latency</a:t>
-            </a:r>
-            <a:endParaRPr lang="en-US" sz="1200" dirty="0"/>
-          </a:p>
-        </p:txBody>
-      </p:sp>
-      <p:sp>
-        <p:nvSpPr>
-          <p:cNvPr id="19" name="Shape 16"/>
-          <p:cNvSpPr/>
-          <p:nvPr/>
-        </p:nvSpPr>
-        <p:spPr>
-          <a:xfrm>
-            <a:off x="5029200" y="2103120"/>
-            <a:ext cx="3657600" cy="731520"/>
-          </a:xfrm>
-          <a:prstGeom prst="rect">
-            <a:avLst/>
-          </a:prstGeom>
-          <a:solidFill>
-            <a:srgbClr val="151829"/>
-          </a:solidFill>
-          <a:ln/>
-        </p:spPr>
-      </p:sp>
-      <p:sp>
-        <p:nvSpPr>
-          <p:cNvPr id="20" name="Text 17"/>
-          <p:cNvSpPr/>
-          <p:nvPr/>
-        </p:nvSpPr>
-        <p:spPr>
-          <a:xfrm>
-            <a:off x="5303520" y="2103120"/>
-            <a:ext cx="1645920" cy="731520"/>
-          </a:xfrm>
-          <a:prstGeom prst="rect">
-            <a:avLst/>
-          </a:prstGeom>
-          <a:noFill/>
-          <a:ln/>
-        </p:spPr>
-        <p:txBody>
-          <a:bodyPr wrap="square" lIns="0" tIns="0" rIns="0" bIns="0" rtlCol="0" anchor="ctr"/>
-          <a:lstStyle/>
-          <a:p>
-            <a:pPr indent="0" marL="0">
-              <a:buNone/>
-            </a:pPr>
-            <a:r>
-              <a:rPr lang="en-US" sz="2400" dirty="0">
-                <a:solidFill>
-                  <a:srgbClr val="14F195"/>
-                </a:solidFill>
-                <a:latin typeface="Arial Black" pitchFamily="34" charset="0"/>
-                <a:ea typeface="Arial Black" pitchFamily="34" charset="-122"/>
-                <a:cs typeface="Arial Black" pitchFamily="34" charset="-120"/>
-              </a:rPr>
-              <a:t>0 Gas</a:t>
-            </a:r>
-            <a:endParaRPr lang="en-US" sz="2400" dirty="0"/>
-          </a:p>
-        </p:txBody>
-      </p:sp>
-      <p:sp>
-        <p:nvSpPr>
-          <p:cNvPr id="21" name="Text 18"/>
-          <p:cNvSpPr/>
-          <p:nvPr/>
-        </p:nvSpPr>
-        <p:spPr>
-          <a:xfrm>
-            <a:off x="6949440" y="2103120"/>
-            <a:ext cx="1645920" cy="731520"/>
-          </a:xfrm>
-          <a:prstGeom prst="rect">
-            <a:avLst/>
-          </a:prstGeom>
-          <a:noFill/>
-          <a:ln/>
-        </p:spPr>
-        <p:txBody>
-          <a:bodyPr wrap="square" lIns="0" tIns="0" rIns="0" bIns="0" rtlCol="0" anchor="ctr"/>
-          <a:lstStyle/>
-          <a:p>
-            <a:pPr indent="0" marL="0">
-              <a:buNone/>
-            </a:pPr>
-            <a:r>
-              <a:rPr lang="en-US" sz="1200" dirty="0">
-                <a:solidFill>
-                  <a:srgbClr val="C4C4D4"/>
-                </a:solidFill>
-                <a:latin typeface="Calibri" pitchFamily="34" charset="0"/>
-                <a:ea typeface="Calibri" pitchFamily="34" charset="-122"/>
-                <a:cs typeface="Calibri" pitchFamily="34" charset="-120"/>
-              </a:rPr>
-              <a:t>Gas Cost</a:t>
-            </a:r>
-            <a:endParaRPr lang="en-US" sz="1200" dirty="0"/>
-          </a:p>
-        </p:txBody>
-      </p:sp>
-      <p:sp>
-        <p:nvSpPr>
-          <p:cNvPr id="22" name="Shape 19"/>
-          <p:cNvSpPr/>
-          <p:nvPr/>
-        </p:nvSpPr>
-        <p:spPr>
-          <a:xfrm>
-            <a:off x="5029200" y="3017520"/>
-            <a:ext cx="3657600" cy="731520"/>
-          </a:xfrm>
-          <a:prstGeom prst="rect">
-            <a:avLst/>
-          </a:prstGeom>
-          <a:solidFill>
-            <a:srgbClr val="151829"/>
-          </a:solidFill>
-          <a:ln/>
-        </p:spPr>
-      </p:sp>
-      <p:sp>
-        <p:nvSpPr>
-          <p:cNvPr id="23" name="Text 20"/>
-          <p:cNvSpPr/>
-          <p:nvPr/>
-        </p:nvSpPr>
-        <p:spPr>
-          <a:xfrm>
-            <a:off x="5303520" y="3017520"/>
-            <a:ext cx="1645920" cy="731520"/>
-          </a:xfrm>
-          <a:prstGeom prst="rect">
-            <a:avLst/>
-          </a:prstGeom>
-          <a:noFill/>
-          <a:ln/>
-        </p:spPr>
-        <p:txBody>
-          <a:bodyPr wrap="square" lIns="0" tIns="0" rIns="0" bIns="0" rtlCol="0" anchor="ctr"/>
-          <a:lstStyle/>
-          <a:p>
-            <a:pPr indent="0" marL="0">
-              <a:buNone/>
-            </a:pPr>
-            <a:r>
-              <a:rPr lang="en-US" sz="2400" dirty="0">
-                <a:solidFill>
-                  <a:srgbClr val="14F195"/>
-                </a:solidFill>
-                <a:latin typeface="Arial Black" pitchFamily="34" charset="0"/>
-                <a:ea typeface="Arial Black" pitchFamily="34" charset="-122"/>
-                <a:cs typeface="Arial Black" pitchFamily="34" charset="-120"/>
-              </a:rPr>
-              <a:t>Batch</a:t>
-            </a:r>
-            <a:endParaRPr lang="en-US" sz="2400" dirty="0"/>
-          </a:p>
-        </p:txBody>
-      </p:sp>
-      <p:sp>
-        <p:nvSpPr>
-          <p:cNvPr id="24" name="Text 21"/>
-          <p:cNvSpPr/>
-          <p:nvPr/>
-        </p:nvSpPr>
-        <p:spPr>
-          <a:xfrm>
-            <a:off x="6949440" y="3017520"/>
-            <a:ext cx="1645920" cy="731520"/>
-          </a:xfrm>
-          <a:prstGeom prst="rect">
-            <a:avLst/>
-          </a:prstGeom>
-          <a:noFill/>
-          <a:ln/>
-        </p:spPr>
-        <p:txBody>
-          <a:bodyPr wrap="square" lIns="0" tIns="0" rIns="0" bIns="0" rtlCol="0" anchor="ctr"/>
-          <a:lstStyle/>
-          <a:p>
-            <a:pPr indent="0" marL="0">
-              <a:buNone/>
-            </a:pPr>
-            <a:r>
-              <a:rPr lang="en-US" sz="1200" dirty="0">
-                <a:solidFill>
-                  <a:srgbClr val="C4C4D4"/>
-                </a:solidFill>
-                <a:latin typeface="Calibri" pitchFamily="34" charset="0"/>
-                <a:ea typeface="Calibri" pitchFamily="34" charset="-122"/>
-                <a:cs typeface="Calibri" pitchFamily="34" charset="-120"/>
-              </a:rPr>
-              <a:t>Merkle Settlement</a:t>
-            </a:r>
-            <a:endParaRPr lang="en-US" sz="1200" dirty="0"/>
-          </a:p>
-        </p:txBody>
-      </p:sp>
-      <p:sp>
-        <p:nvSpPr>
-          <p:cNvPr id="25" name="Shape 22"/>
-          <p:cNvSpPr/>
-          <p:nvPr/>
-        </p:nvSpPr>
-        <p:spPr>
-          <a:xfrm>
-            <a:off x="457200" y="4023360"/>
-            <a:ext cx="8229600" cy="594360"/>
+              <a:t>Use cases: large-scale identity, low-cost DID management</a:t>
+            </a:r>
+            <a:endParaRPr lang="en-US" sz="900" dirty="0"/>
+          </a:p>
+        </p:txBody>
+      </p:sp>
+      <p:sp>
+        <p:nvSpPr>
+          <p:cNvPr id="16" name="Shape 13"/>
+          <p:cNvSpPr/>
+          <p:nvPr/>
+        </p:nvSpPr>
+        <p:spPr>
+          <a:xfrm>
+            <a:off x="457200" y="4709160"/>
+            <a:ext cx="8229600" cy="320040"/>
           </a:xfrm>
           <a:prstGeom prst="rect">
             <a:avLst/>
@@ -15537,14 +14676,14 @@
       </p:sp>
       <p:sp>
         <p:nvSpPr>
-          <p:cNvPr id="26" name="Text 23"/>
-          <p:cNvSpPr/>
-          <p:nvPr/>
-        </p:nvSpPr>
-        <p:spPr>
-          <a:xfrm>
-            <a:off x="731520" y="4023360"/>
-            <a:ext cx="7772400" cy="594360"/>
+          <p:cNvPr id="17" name="Text 14"/>
+          <p:cNvSpPr/>
+          <p:nvPr/>
+        </p:nvSpPr>
+        <p:spPr>
+          <a:xfrm>
+            <a:off x="731520" y="4709160"/>
+            <a:ext cx="7772400" cy="320040"/>
           </a:xfrm>
           <a:prstGeom prst="rect">
             <a:avLst/>
@@ -15560,17 +14699,17 @@
               <a:buNone/>
             </a:pPr>
             <a:r>
-              <a:rPr lang="en-US" sz="1100" dirty="0">
-                <a:solidFill>
-                  <a:srgbClr val="14F195"/>
+              <a:rPr lang="en-US" sz="900" dirty="0">
+                <a:solidFill>
+                  <a:srgbClr val="8888A0"/>
                 </a:solidFill>
                 <a:latin typeface="Consolas" pitchFamily="34" charset="0"/>
                 <a:ea typeface="Consolas" pitchFamily="34" charset="-122"/>
                 <a:cs typeface="Consolas" pitchFamily="34" charset="-120"/>
               </a:rPr>
-              <a:t>Voucher = SHA256(channel_id || seq || amount) + Ed25519 Signature</a:t>
-            </a:r>
-            <a:endParaRPr lang="en-US" sz="1100" dirty="0"/>
+              <a:t>Not currently in use. Planned for future integration. Architecture has reserved interfaces.</a:t>
+            </a:r>
+            <a:endParaRPr lang="en-US" sz="900" dirty="0"/>
           </a:p>
         </p:txBody>
       </p:sp>

</xml_diff>